<commit_message>
Add maternal care affordability angle
</commit_message>
<xml_diff>
--- a/dhruvil-files/GeoGap-Planner-Demo.pptx
+++ b/dhruvil-files/GeoGap-Planner-Demo.pptx
@@ -13,6 +13,7 @@
     <p:sldId id="261" r:id="rId12"/>
     <p:sldId id="262" r:id="rId13"/>
     <p:sldId id="263" r:id="rId14"/>
+    <p:sldId id="264" r:id="rId15"/>
   </p:sldIdLst>
   <p:sldSz cx="12191695" cy="6858000" type="screen4x3"/>
   <p:notesSz cx="6858000" cy="9144000"/>
@@ -3884,7 +3885,7 @@
                 </a:solidFill>
                 <a:latin typeface="Aptos"/>
               </a:rPr>
-              <a:t>Demand proxies: maternal health, child health, anemia, diabetes, hypertension, insurance, education, nutrition, and affordability context.</a:t>
+              <a:t>Demand proxies: maternal health, child health, anemia, diabetes, hypertension, insurance, education, nutrition, and affordability context, including delivery out-of-pocket signals.</a:t>
             </a:r>
           </a:p>
         </p:txBody>
@@ -3932,6 +3933,286 @@
 </file>
 
 <file path=ppt/slides/slide4.xml><?xml version="1.0" encoding="utf-8"?>
+<p:sld xmlns:a="http://schemas.openxmlformats.org/drawingml/2006/main" xmlns:p="http://schemas.openxmlformats.org/presentationml/2006/main" xmlns:r="http://schemas.openxmlformats.org/officeDocument/2006/relationships">
+  <p:cSld>
+    <p:bg>
+      <p:bgPr>
+        <a:solidFill>
+          <a:srgbClr val="F4F0E7"/>
+        </a:solidFill>
+        <a:effectLst/>
+      </p:bgPr>
+    </p:bg>
+    <p:spTree>
+      <p:nvGrpSpPr>
+        <p:cNvPr id="1" name=""/>
+        <p:cNvGrpSpPr/>
+        <p:nvPr/>
+      </p:nvGrpSpPr>
+      <p:grpSpPr/>
+      <p:sp>
+        <p:nvSpPr>
+          <p:cNvPr id="2" name="TextBox 1"/>
+          <p:cNvSpPr txBox="1"/>
+          <p:nvPr/>
+        </p:nvSpPr>
+        <p:spPr>
+          <a:xfrm>
+            <a:off x="640080" y="457200"/>
+            <a:ext cx="10789920" cy="731520"/>
+          </a:xfrm>
+          <a:prstGeom prst="rect">
+            <a:avLst/>
+          </a:prstGeom>
+          <a:noFill/>
+        </p:spPr>
+        <p:txBody>
+          <a:bodyPr wrap="none">
+            <a:spAutoFit/>
+          </a:bodyPr>
+          <a:lstStyle/>
+          <a:p>
+            <a:r>
+              <a:rPr sz="2800" b="1">
+                <a:solidFill>
+                  <a:srgbClr val="1C222D"/>
+                </a:solidFill>
+                <a:latin typeface="Aptos Display"/>
+              </a:rPr>
+              <a:t>Maternal care affordability</a:t>
+            </a:r>
+          </a:p>
+        </p:txBody>
+      </p:sp>
+      <p:sp>
+        <p:nvSpPr>
+          <p:cNvPr id="3" name="TextBox 2"/>
+          <p:cNvSpPr txBox="1"/>
+          <p:nvPr/>
+        </p:nvSpPr>
+        <p:spPr>
+          <a:xfrm>
+            <a:off x="658368" y="1078992"/>
+            <a:ext cx="10515600" cy="457200"/>
+          </a:xfrm>
+          <a:prstGeom prst="rect">
+            <a:avLst/>
+          </a:prstGeom>
+          <a:noFill/>
+        </p:spPr>
+        <p:txBody>
+          <a:bodyPr wrap="none">
+            <a:spAutoFit/>
+          </a:bodyPr>
+          <a:lstStyle/>
+          <a:p>
+            <a:r>
+              <a:rPr sz="1300">
+                <a:solidFill>
+                  <a:srgbClr val="606C7E"/>
+                </a:solidFill>
+                <a:latin typeface="Aptos"/>
+              </a:rPr>
+              <a:t>A specialty-specific view for delivery and maternity expansion.</a:t>
+            </a:r>
+          </a:p>
+        </p:txBody>
+      </p:sp>
+      <p:sp>
+        <p:nvSpPr>
+          <p:cNvPr id="4" name="TextBox 3"/>
+          <p:cNvSpPr txBox="1"/>
+          <p:nvPr/>
+        </p:nvSpPr>
+        <p:spPr>
+          <a:xfrm>
+            <a:off x="731520" y="1645920"/>
+            <a:ext cx="5486400" cy="4389120"/>
+          </a:xfrm>
+          <a:prstGeom prst="rect">
+            <a:avLst/>
+          </a:prstGeom>
+          <a:noFill/>
+        </p:spPr>
+        <p:txBody>
+          <a:bodyPr wrap="square">
+            <a:spAutoFit/>
+          </a:bodyPr>
+          <a:lstStyle/>
+          <a:p>
+            <a:pPr>
+              <a:spcAft>
+                <a:spcPts val="800"/>
+              </a:spcAft>
+              <a:defRPr sz="1900">
+                <a:solidFill>
+                  <a:srgbClr val="1C222D"/>
+                </a:solidFill>
+                <a:latin typeface="Aptos"/>
+              </a:defRPr>
+            </a:pPr>
+            <a:r>
+              <a:t>When maternal care is selected, the app can surface a modeled delivery-cost view.</a:t>
+            </a:r>
+          </a:p>
+          <a:p>
+            <a:pPr>
+              <a:spcAft>
+                <a:spcPts val="800"/>
+              </a:spcAft>
+              <a:defRPr sz="1900">
+                <a:solidFill>
+                  <a:srgbClr val="1C222D"/>
+                </a:solidFill>
+                <a:latin typeface="Aptos"/>
+              </a:defRPr>
+            </a:pPr>
+            <a:r>
+              <a:t>The strongest current proxy is average out-of-pocket expenditure per delivery in a public facility.</a:t>
+            </a:r>
+          </a:p>
+          <a:p>
+            <a:pPr>
+              <a:spcAft>
+                <a:spcPts val="800"/>
+              </a:spcAft>
+              <a:defRPr sz="1900">
+                <a:solidFill>
+                  <a:srgbClr val="1C222D"/>
+                </a:solidFill>
+                <a:latin typeface="Aptos"/>
+              </a:defRPr>
+            </a:pPr>
+            <a:r>
+              <a:t>We combine that with district insurance coverage and public vs private provider mix.</a:t>
+            </a:r>
+          </a:p>
+          <a:p>
+            <a:pPr>
+              <a:spcAft>
+                <a:spcPts val="800"/>
+              </a:spcAft>
+              <a:defRPr sz="1900">
+                <a:solidFill>
+                  <a:srgbClr val="1C222D"/>
+                </a:solidFill>
+                <a:latin typeface="Aptos"/>
+              </a:defRPr>
+            </a:pPr>
+            <a:r>
+              <a:t>This helps users favor lower-cost or better-covered care options for patients.</a:t>
+            </a:r>
+          </a:p>
+        </p:txBody>
+      </p:sp>
+      <p:sp>
+        <p:nvSpPr>
+          <p:cNvPr id="5" name="Rounded Rectangle 4"/>
+          <p:cNvSpPr/>
+          <p:nvPr/>
+        </p:nvSpPr>
+        <p:spPr>
+          <a:xfrm>
+            <a:off x="6675120" y="1737360"/>
+            <a:ext cx="4572000" cy="3291840"/>
+          </a:xfrm>
+          <a:prstGeom prst="roundRect">
+            <a:avLst/>
+          </a:prstGeom>
+          <a:solidFill>
+            <a:srgbClr val="139CA4"/>
+          </a:solidFill>
+          <a:ln>
+            <a:solidFill>
+              <a:srgbClr val="139CA4"/>
+            </a:solidFill>
+          </a:ln>
+        </p:spPr>
+        <p:style>
+          <a:lnRef idx="1">
+            <a:schemeClr val="accent1"/>
+          </a:lnRef>
+          <a:fillRef idx="3">
+            <a:schemeClr val="accent1"/>
+          </a:fillRef>
+          <a:effectRef idx="2">
+            <a:schemeClr val="accent1"/>
+          </a:effectRef>
+          <a:fontRef idx="minor">
+            <a:schemeClr val="lt1"/>
+          </a:fontRef>
+        </p:style>
+        <p:txBody>
+          <a:bodyPr rtlCol="0" anchor="ctr"/>
+          <a:lstStyle/>
+          <a:p>
+            <a:pPr algn="ctr"/>
+            <a:r>
+              <a:rPr sz="1700" b="1">
+                <a:solidFill>
+                  <a:srgbClr val="FFFFFF"/>
+                </a:solidFill>
+                <a:latin typeface="Aptos Display"/>
+              </a:rPr>
+              <a:t>What the model should show</a:t>
+            </a:r>
+          </a:p>
+          <a:p>
+            <a:r>
+              <a:rPr sz="1200">
+                <a:solidFill>
+                  <a:srgbClr val="FFFFFF"/>
+                </a:solidFill>
+                <a:latin typeface="Aptos"/>
+              </a:rPr>
+              <a:t>District delivery-cost estimate, affordability label, and guidance on how the practice can serve patients better on cost and access.</a:t>
+            </a:r>
+          </a:p>
+        </p:txBody>
+      </p:sp>
+      <p:sp>
+        <p:nvSpPr>
+          <p:cNvPr id="6" name="TextBox 5"/>
+          <p:cNvSpPr txBox="1"/>
+          <p:nvPr/>
+        </p:nvSpPr>
+        <p:spPr>
+          <a:xfrm>
+            <a:off x="640080" y="6400800"/>
+            <a:ext cx="10972800" cy="228600"/>
+          </a:xfrm>
+          <a:prstGeom prst="rect">
+            <a:avLst/>
+          </a:prstGeom>
+          <a:noFill/>
+        </p:spPr>
+        <p:txBody>
+          <a:bodyPr wrap="none">
+            <a:spAutoFit/>
+          </a:bodyPr>
+          <a:lstStyle/>
+          <a:p>
+            <a:r>
+              <a:rPr sz="900">
+                <a:solidFill>
+                  <a:srgbClr val="606C7E"/>
+                </a:solidFill>
+                <a:latin typeface="Aptos"/>
+              </a:rPr>
+              <a:t>Maternal care uses delivery-cost modeling, not general procedure pricing.</a:t>
+            </a:r>
+          </a:p>
+        </p:txBody>
+      </p:sp>
+    </p:spTree>
+  </p:cSld>
+  <p:clrMapOvr>
+    <a:masterClrMapping/>
+  </p:clrMapOvr>
+</p:sld>
+</file>
+
+<file path=ppt/slides/slide5.xml><?xml version="1.0" encoding="utf-8"?>
 <p:sld xmlns:a="http://schemas.openxmlformats.org/drawingml/2006/main" xmlns:p="http://schemas.openxmlformats.org/presentationml/2006/main" xmlns:r="http://schemas.openxmlformats.org/officeDocument/2006/relationships">
   <p:cSld>
     <p:bg>
@@ -4272,7 +4553,7 @@
                 </a:solidFill>
                 <a:latin typeface="Aptos"/>
               </a:rPr>
-              <a:t>An evidence-backed shortlist of expansion locations with nearby competitors, trust labels, affordability labels, and notes the user can save.</a:t>
+              <a:t>An evidence-backed shortlist of expansion locations with nearby competitors, trust labels, affordability labels, and notes the user can save. For maternal care, this includes delivery affordability cues.</a:t>
             </a:r>
           </a:p>
         </p:txBody>
@@ -4319,7 +4600,7 @@
 </p:sld>
 </file>
 
-<file path=ppt/slides/slide5.xml><?xml version="1.0" encoding="utf-8"?>
+<file path=ppt/slides/slide6.xml><?xml version="1.0" encoding="utf-8"?>
 <p:sld xmlns:a="http://schemas.openxmlformats.org/drawingml/2006/main" xmlns:p="http://schemas.openxmlformats.org/presentationml/2006/main" xmlns:r="http://schemas.openxmlformats.org/officeDocument/2006/relationships">
   <p:cSld>
     <p:bg>
@@ -4583,7 +4864,7 @@
 </p:sld>
 </file>
 
-<file path=ppt/slides/slide6.xml><?xml version="1.0" encoding="utf-8"?>
+<file path=ppt/slides/slide7.xml><?xml version="1.0" encoding="utf-8"?>
 <p:sld xmlns:a="http://schemas.openxmlformats.org/drawingml/2006/main" xmlns:p="http://schemas.openxmlformats.org/presentationml/2006/main" xmlns:r="http://schemas.openxmlformats.org/officeDocument/2006/relationships">
   <p:cSld>
     <p:bg>
@@ -4832,7 +5113,7 @@
                 </a:solidFill>
                 <a:latin typeface="Aptos"/>
               </a:rPr>
-              <a:t>We are building an expansion-intelligence map that identifies underserved specialty geographies using trust-scored facility data and a directional affordability lens.</a:t>
+              <a:t>We are building an expansion-intelligence map that identifies underserved specialty geographies using trust-scored facility data, with maternal care delivery-cost modeling as a specialty-specific affordability view.</a:t>
             </a:r>
           </a:p>
         </p:txBody>
@@ -4879,7 +5160,7 @@
 </p:sld>
 </file>
 
-<file path=ppt/slides/slide7.xml><?xml version="1.0" encoding="utf-8"?>
+<file path=ppt/slides/slide8.xml><?xml version="1.0" encoding="utf-8"?>
 <p:sld xmlns:a="http://schemas.openxmlformats.org/drawingml/2006/main" xmlns:p="http://schemas.openxmlformats.org/presentationml/2006/main" xmlns:r="http://schemas.openxmlformats.org/officeDocument/2006/relationships">
   <p:cSld>
     <p:bg>
@@ -5267,7 +5548,7 @@
 </p:sld>
 </file>
 
-<file path=ppt/slides/slide8.xml><?xml version="1.0" encoding="utf-8"?>
+<file path=ppt/slides/slide9.xml><?xml version="1.0" encoding="utf-8"?>
 <p:sld xmlns:a="http://schemas.openxmlformats.org/drawingml/2006/main" xmlns:p="http://schemas.openxmlformats.org/presentationml/2006/main" xmlns:r="http://schemas.openxmlformats.org/officeDocument/2006/relationships">
   <p:cSld>
     <p:bg>
@@ -5413,7 +5694,7 @@
                 </a:solidFill>
                 <a:latin typeface="Aptos"/>
               </a:rPr>
-              <a:t>A private internal medicine group wants to expand into a new district. They open GeoGap Planner, choose internal medicine, and immediately see areas where specialty supply is thin but district disease burden is high. Each recommendation includes nearby competitor facilities, source-backed evidence, and a confidence label. The team saves the best locations and exports a shortlist for review.</a:t>
+              <a:t>A private internal medicine group wants to expand into a new district. A maternal care team selects maternity planning and sees district delivery-cost estimates, insurance coverage context, and nearby facilities that are better positioned for affordable childbirth care. Each recommendation includes nearby competitor facilities, source-backed evidence, and a confidence label. The team saves the best locations and exports a shortlist for review.</a:t>
             </a:r>
           </a:p>
         </p:txBody>

</xml_diff>